<commit_message>
docs: fix organelle role labeling in deck (Leucoplast=energy store, Chloroplast=division)
</commit_message>
<xml_diff>
--- a/docs/Celular-Autonoma-v2.pptx
+++ b/docs/Celular-Autonoma-v2.pptx
@@ -75,7 +75,7 @@
         <p:txBody>
           <a:bodyPr/>
           <a:p>
-            <a:fld id="{CE43D632-954D-469A-8090-091063691D5C}" type="slidenum">
+            <a:fld id="{F5FF0752-1753-4395-B447-2CF2B9540270}" type="slidenum">
               <a:t>&lt;#&gt;</a:t>
             </a:fld>
           </a:p>
@@ -245,7 +245,7 @@
         <p:txBody>
           <a:bodyPr/>
           <a:p>
-            <a:fld id="{6E67A379-45D7-4DB3-BCE1-BA4EB44227D1}" type="slidenum">
+            <a:fld id="{7E2EDA96-5A3C-44AE-9243-7BA5F04D80BC}" type="slidenum">
               <a:t>&lt;#&gt;</a:t>
             </a:fld>
           </a:p>
@@ -927,7 +927,7 @@
             <a:pPr indent="0" algn="r">
               <a:buNone/>
             </a:pPr>
-            <a:fld id="{4374DBBA-C5B2-4B9F-A42B-9F980087C2E1}" type="slidenum">
+            <a:fld id="{F20F0465-B9E1-4F10-A03B-C7BD1A217D0B}" type="slidenum">
               <a:rPr lang="en-US" sz="1400" b="0" u="none" strike="noStrike">
                 <a:solidFill>
                   <a:srgbClr val="000000"/>
@@ -5105,7 +5105,7 @@
                 <a:uFillTx/>
                 <a:latin typeface="DejaVu Sans"/>
               </a:rPr>
-              <a:t>-  Nucleus holds identity + linked modules; Chloroplast stores energy (= capital); and so on.</a:t>
+              <a:t>-  Nucleus holds identity + linked modules; Chloroplast drives division; Leucoplast stores energy (= capital).</a:t>
             </a:r>
             <a:endParaRPr lang="en-US" sz="1900" b="0" u="none" strike="noStrike">
               <a:solidFill>

</xml_diff>